<commit_message>
SIH_AVIAN_FINAL: Section 4 re-fly result, deck source files, coordination handover
Section 4 re-fly (B3): mission/coverage_mission_s4_flight_log.json for the
571-waypoint post-fix mission (150 original + 421 A* detour legs).
66/571 stuck, worst position-hold error 273.5 m, 265 skipped on respawn
budget -- reported as-is, not yet reconciled against the 150-waypoint
"before" baseline (67/150 = 44.7% stuck, 201 m worst error).

deck/src/: build.py, template.pptx, CAM_10_TRUSS.jpg -- the deck build
script and its inputs, recovered after a disconnect and moved into the
repo so the deck can be rebuilt with `cd deck/src && python3 build.py`.

SIH_AVIAN_HANDOVER_FOR_NEW_CHAT.md: coordination handover for the chat
tracking submission timeline/rules while this session does the build work.

deck/SIH26201_AVIAN_Idea.{pdf,pptx}: latest local build output.

Co-Authored-By: Claude Sonnet 5 <noreply@anthropic.com>
</commit_message>
<xml_diff>
--- a/SIH_AVIAN_FINAL/deck/SIH26201_AVIAN_Idea.pptx
+++ b/SIH_AVIAN_FINAL/deck/SIH26201_AVIAN_Idea.pptx
@@ -5770,7 +5770,7 @@
                 </a:solidFill>
                 <a:latin typeface="Arial"/>
               </a:rPr>
-              <a:t> [Team ID]</a:t>
+              <a:t> 129300</a:t>
             </a:r>
           </a:p>
           <a:p>
@@ -5795,7 +5795,7 @@
                 </a:solidFill>
                 <a:latin typeface="Arial"/>
               </a:rPr>
-              <a:t> - [Team Name]</a:t>
+              <a:t> - @TRINETRA</a:t>
             </a:r>
             <a:endParaRPr lang="en-IN" sz="2400" b="1" dirty="0">
               <a:latin typeface="Arial" panose="020B0604020202020204" pitchFamily="34" charset="0"/>
@@ -6074,13 +6074,13 @@
           </a:fontRef>
         </p:style>
         <p:txBody>
-          <a:bodyPr rtlCol="0" anchor="ctr"/>
+          <a:bodyPr rtlCol="0" anchor="ctr" wrap="none"/>
           <a:lstStyle/>
           <a:p>
             <a:pPr algn="ctr"/>
             <a:r>
-              <a:rPr lang="en-US" dirty="0"/>
-              <a:t>[Team Name]</a:t>
+              <a:rPr lang="en-US" dirty="0" sz="1100" b="1"/>
+              <a:t>TRINETRA</a:t>
             </a:r>
             <a:endParaRPr lang="en-IN" dirty="0"/>
           </a:p>
@@ -6829,13 +6829,13 @@
           </a:fontRef>
         </p:style>
         <p:txBody>
-          <a:bodyPr rtlCol="0" anchor="ctr"/>
+          <a:bodyPr rtlCol="0" anchor="ctr" wrap="none"/>
           <a:lstStyle/>
           <a:p>
             <a:pPr algn="ctr"/>
             <a:r>
-              <a:rPr lang="en-US" dirty="0"/>
-              <a:t>[Team Name]</a:t>
+              <a:rPr lang="en-US" dirty="0" sz="1100" b="1"/>
+              <a:t>TRINETRA</a:t>
             </a:r>
             <a:endParaRPr lang="en-IN" dirty="0"/>
           </a:p>
@@ -9153,13 +9153,13 @@
           </a:fontRef>
         </p:style>
         <p:txBody>
-          <a:bodyPr rtlCol="0" anchor="ctr"/>
+          <a:bodyPr rtlCol="0" anchor="ctr" wrap="none"/>
           <a:lstStyle/>
           <a:p>
             <a:pPr algn="ctr"/>
             <a:r>
-              <a:rPr lang="en-US" dirty="0"/>
-              <a:t>[Team Name]</a:t>
+              <a:rPr lang="en-US" dirty="0" sz="1100" b="1"/>
+              <a:t>TRINETRA</a:t>
             </a:r>
             <a:endParaRPr lang="en-IN" dirty="0"/>
           </a:p>
@@ -10250,13 +10250,13 @@
           </a:fontRef>
         </p:style>
         <p:txBody>
-          <a:bodyPr rtlCol="0" anchor="ctr"/>
+          <a:bodyPr rtlCol="0" anchor="ctr" wrap="none"/>
           <a:lstStyle/>
           <a:p>
             <a:pPr algn="ctr"/>
             <a:r>
-              <a:rPr lang="en-US" dirty="0"/>
-              <a:t>[Team Name]</a:t>
+              <a:rPr lang="en-US" dirty="0" sz="1100" b="1"/>
+              <a:t>TRINETRA</a:t>
             </a:r>
             <a:endParaRPr lang="en-IN" dirty="0"/>
           </a:p>
@@ -11629,13 +11629,13 @@
           </a:fontRef>
         </p:style>
         <p:txBody>
-          <a:bodyPr rtlCol="0" anchor="ctr"/>
+          <a:bodyPr rtlCol="0" anchor="ctr" wrap="none"/>
           <a:lstStyle/>
           <a:p>
             <a:pPr algn="ctr"/>
             <a:r>
-              <a:rPr lang="en-US" dirty="0"/>
-              <a:t>[Team Name]</a:t>
+              <a:rPr lang="en-US" dirty="0" sz="1100" b="1"/>
+              <a:t>TRINETRA</a:t>
             </a:r>
             <a:endParaRPr lang="en-IN" dirty="0"/>
           </a:p>

</xml_diff>

<commit_message>
Deck: replace pending placeholders with measured Stage 2 results
Slide 3 now states the Gazebo status (autonomous flight validated, full-corridor
coverage and live detection still in progress); slide 4 shows the measured
coverage, recall, avoidance and stuck/collision numbers instead of pending
markers. Rebuilt PPTX and PDF.

Co-Authored-By: Claude Sonnet 5 <noreply@anthropic.com>
</commit_message>
<xml_diff>
--- a/SIH_AVIAN_FINAL/deck/SIH26201_AVIAN_Idea.pptx
+++ b/SIH_AVIAN_FINAL/deck/SIH26201_AVIAN_Idea.pptx
@@ -8815,7 +8815,7 @@
                 </a:solidFill>
                 <a:latin typeface="Arial"/>
               </a:rPr>
-              <a:t>Next: </a:t>
+              <a:t>Gazebo: </a:t>
             </a:r>
             <a:r>
               <a:rPr sz="1250" b="0" i="0">
@@ -8824,7 +8824,7 @@
                 </a:solidFill>
                 <a:latin typeface="Arial"/>
               </a:rPr>
-              <a:t>run the same stack live in Gazebo + ROS 2, then on PX4 hardware.</a:t>
+              <a:t>fully autonomous flight validated (real takeoff/hover/land, sensed obstacle avoidance confirmed collision-free); full-corridor autonomous coverage and live defect detection in Gazebo remain in progress.</a:t>
             </a:r>
           </a:p>
         </p:txBody>
@@ -9291,11 +9291,11 @@
             <a:r>
               <a:rPr sz="2000" b="1" i="0">
                 <a:solidFill>
-                  <a:srgbClr val="596270"/>
-                </a:solidFill>
-                <a:latin typeface="Arial"/>
-              </a:rPr>
-              <a:t>—</a:t>
+                  <a:srgbClr val="0070C0"/>
+                </a:solidFill>
+                <a:latin typeface="Arial"/>
+              </a:rPr>
+              <a:t>56.66%</a:t>
             </a:r>
           </a:p>
         </p:txBody>
@@ -9326,11 +9326,11 @@
             <a:r>
               <a:rPr sz="1100" b="0" i="0">
                 <a:solidFill>
-                  <a:srgbClr val="596270"/>
-                </a:solidFill>
-                <a:latin typeface="Arial"/>
-              </a:rPr>
-              <a:t>bridge surface coverage — route planned with no defect data (pending freeze)</a:t>
+                  <a:srgbClr val="1F2A44"/>
+                </a:solidFill>
+                <a:latin typeface="Arial"/>
+              </a:rPr>
+              <a:t>bridge surface coverage — route planned with no defect data</a:t>
             </a:r>
           </a:p>
         </p:txBody>
@@ -9361,11 +9361,11 @@
             <a:r>
               <a:rPr sz="2000" b="1" i="0">
                 <a:solidFill>
-                  <a:srgbClr val="596270"/>
-                </a:solidFill>
-                <a:latin typeface="Arial"/>
-              </a:rPr>
-              <a:t>—</a:t>
+                  <a:srgbClr val="0070C0"/>
+                </a:solidFill>
+                <a:latin typeface="Arial"/>
+              </a:rPr>
+              <a:t>39/73</a:t>
             </a:r>
           </a:p>
         </p:txBody>
@@ -9396,11 +9396,11 @@
             <a:r>
               <a:rPr sz="1100" b="0" i="0">
                 <a:solidFill>
-                  <a:srgbClr val="596270"/>
-                </a:solidFill>
-                <a:latin typeface="Arial"/>
-              </a:rPr>
-              <a:t>known defects fell inside a settled camera view (pending freeze)</a:t>
+                  <a:srgbClr val="1F2A44"/>
+                </a:solidFill>
+                <a:latin typeface="Arial"/>
+              </a:rPr>
+              <a:t>known defects fell inside a settled camera view (recall)</a:t>
             </a:r>
           </a:p>
         </p:txBody>
@@ -9431,11 +9431,11 @@
             <a:r>
               <a:rPr sz="2000" b="1" i="0">
                 <a:solidFill>
-                  <a:srgbClr val="596270"/>
-                </a:solidFill>
-                <a:latin typeface="Arial"/>
-              </a:rPr>
-              <a:t>—</a:t>
+                  <a:srgbClr val="0070C0"/>
+                </a:solidFill>
+                <a:latin typeface="Arial"/>
+              </a:rPr>
+              <a:t>239/239</a:t>
             </a:r>
           </a:p>
         </p:txBody>
@@ -9466,11 +9466,11 @@
             <a:r>
               <a:rPr sz="1100" b="0" i="0">
                 <a:solidFill>
-                  <a:srgbClr val="596270"/>
-                </a:solidFill>
-                <a:latin typeface="Arial"/>
-              </a:rPr>
-              <a:t>flight-log entries show avoidance driven by the sensor, not a map (pending freeze)</a:t>
+                  <a:srgbClr val="1F2A44"/>
+                </a:solidFill>
+                <a:latin typeface="Arial"/>
+              </a:rPr>
+              <a:t>flight-log entries show avoidance driven by the sensor, not a map (6,492 avoidance reactions triggered)</a:t>
             </a:r>
           </a:p>
         </p:txBody>
@@ -9501,11 +9501,11 @@
             <a:r>
               <a:rPr sz="2000" b="1" i="0">
                 <a:solidFill>
-                  <a:srgbClr val="596270"/>
-                </a:solidFill>
-                <a:latin typeface="Arial"/>
-              </a:rPr>
-              <a:t>—</a:t>
+                  <a:srgbClr val="0070C0"/>
+                </a:solidFill>
+                <a:latin typeface="Arial"/>
+              </a:rPr>
+              <a:t>67/150</a:t>
             </a:r>
           </a:p>
         </p:txBody>
@@ -9536,11 +9536,11 @@
             <a:r>
               <a:rPr sz="1100" b="0" i="0">
                 <a:solidFill>
-                  <a:srgbClr val="596270"/>
-                </a:solidFill>
-                <a:latin typeface="Arial"/>
-              </a:rPr>
-              <a:t>waypoints with a collision or stall, before vs after sensed avoidance (pending freeze)</a:t>
+                  <a:srgbClr val="1F2A44"/>
+                </a:solidFill>
+                <a:latin typeface="Arial"/>
+              </a:rPr>
+              <a:t>waypoints stuck or collided (44.7%) — reported Stage 2 baseline</a:t>
             </a:r>
           </a:p>
         </p:txBody>
@@ -9747,7 +9747,7 @@
                           </a:solidFill>
                           <a:latin typeface="Arial"/>
                         </a:rPr>
-                        <a:t>Collisions in the dense steel truss: stuck/collision rate before → after the Section 4 fix is pending the freeze — see the stat at left</a:t>
+                        <a:t>Collisions in the dense steel truss: 44.7% of waypoints stuck or collided (67/150) — reported Stage 2 baseline, see the stat at left</a:t>
                       </a:r>
                     </a:p>
                   </a:txBody>

</xml_diff>